<commit_message>
volvemos a versión anterior
</commit_message>
<xml_diff>
--- a/CineClip_Presentacion_TFG.pptx
+++ b/CineClip_Presentacion_TFG.pptx
@@ -5153,10 +5153,10 @@
       </p:sp>
       <p:pic>
         <p:nvPicPr>
-          <p:cNvPr id="22" name="Imagen 21">
+          <p:cNvPr id="20" name="Imagen 19">
             <a:extLst>
               <a:ext uri="{FF2B5EF4-FFF2-40B4-BE49-F238E27FC236}">
-                <a16:creationId xmlns:a16="http://schemas.microsoft.com/office/drawing/2014/main" id="{C3EADD94-807C-4842-9208-0E5B2CFC0C20}"/>
+                <a16:creationId xmlns:a16="http://schemas.microsoft.com/office/drawing/2014/main" id="{86167FE3-DA36-49D0-BA8E-858567B3F160}"/>
               </a:ext>
             </a:extLst>
           </p:cNvPr>
@@ -5173,8 +5173,8 @@
         </p:blipFill>
         <p:spPr>
           <a:xfrm>
-            <a:off x="5960508" y="1028297"/>
-            <a:ext cx="2269092" cy="2310455"/>
+            <a:off x="6204767" y="1298448"/>
+            <a:ext cx="2014353" cy="2019558"/>
           </a:xfrm>
           <a:prstGeom prst="rect">
             <a:avLst/>

</xml_diff>